<commit_message>
Add dashboard mockup slide (11 slides total)
</commit_message>
<xml_diff>
--- a/FlowDesk-Casino-VIP-Telegram-Proposal.pptx
+++ b/FlowDesk-Casino-VIP-Telegram-Proposal.pptx
@@ -15,9 +15,10 @@
     <p:sldId id="263" r:id="rId9"/>
     <p:sldId id="264" r:id="rId10"/>
     <p:sldId id="265" r:id="rId11"/>
+    <p:sldId id="266" r:id="rId12"/>
   </p:sldIdLst>
   <p:notesMasterIdLst>
-    <p:notesMasterId r:id="rId12"/>
+    <p:notesMasterId r:id="rId13"/>
   </p:notesMasterIdLst>
   <p:sldSz cx="9144000" cy="5143500"/>
   <p:notesSz cx="5143500" cy="9144000"/>
@@ -623,6 +624,94 @@
             <a:fld id="{F7021451-1387-4CA6-816F-3879F97B5CBC}" type="slidenum">
               <a:rPr lang="en-US"/>
               <a:t>10</a:t>
+            </a:fld>
+            <a:endParaRPr lang="en-US"/>
+          </a:p>
+        </p:txBody>
+      </p:sp>
+    </p:spTree>
+    <p:extLst>
+      <p:ext uri="{BB962C8B-B14F-4D97-AF65-F5344CB8AC3E}">
+        <p14:creationId xmlns:p14="http://schemas.microsoft.com/office/powerpoint/2010/main" val="1024086991"/>
+      </p:ext>
+    </p:extLst>
+  </p:cSld>
+  <p:clrMapOvr>
+    <a:masterClrMapping/>
+  </p:clrMapOvr>
+</p:notes>
+</file>
+
+<file path=ppt/notesSlides/notesSlide11.xml><?xml version="1.0" encoding="utf-8"?>
+<p:notes xmlns:a="http://schemas.openxmlformats.org/drawingml/2006/main" xmlns:r="http://schemas.openxmlformats.org/officeDocument/2006/relationships" xmlns:p="http://schemas.openxmlformats.org/presentationml/2006/main">
+  <p:cSld>
+    <p:spTree>
+      <p:nvGrpSpPr>
+        <p:cNvPr id="1" name=""/>
+        <p:cNvGrpSpPr/>
+        <p:nvPr/>
+      </p:nvGrpSpPr>
+      <p:grpSpPr>
+        <a:xfrm>
+          <a:off x="0" y="0"/>
+          <a:ext cx="0" cy="0"/>
+          <a:chOff x="0" y="0"/>
+          <a:chExt cx="0" cy="0"/>
+        </a:xfrm>
+      </p:grpSpPr>
+      <p:sp>
+        <p:nvSpPr>
+          <p:cNvPr id="2" name="Slide Image Placeholder 1"/>
+          <p:cNvSpPr>
+            <a:spLocks noGrp="1" noRot="1" noChangeAspect="1"/>
+          </p:cNvSpPr>
+          <p:nvPr>
+            <p:ph type="sldImg"/>
+          </p:nvPr>
+        </p:nvSpPr>
+        <p:spPr/>
+      </p:sp>
+      <p:sp>
+        <p:nvSpPr>
+          <p:cNvPr id="3" name="Notes Placeholder 2"/>
+          <p:cNvSpPr>
+            <a:spLocks noGrp="1"/>
+          </p:cNvSpPr>
+          <p:nvPr>
+            <p:ph type="body" idx="1"/>
+          </p:nvPr>
+        </p:nvSpPr>
+        <p:spPr/>
+        <p:txBody>
+          <a:bodyPr/>
+          <a:lstStyle/>
+          <a:p>
+            <a:r>
+              <a:rPr lang="en-US" dirty="0"/>
+              <a:t/>
+            </a:r>
+            <a:endParaRPr lang="en-US" dirty="0"/>
+          </a:p>
+        </p:txBody>
+      </p:sp>
+      <p:sp>
+        <p:nvSpPr>
+          <p:cNvPr id="4" name="Slide Number Placeholder 3"/>
+          <p:cNvSpPr>
+            <a:spLocks noGrp="1"/>
+          </p:cNvSpPr>
+          <p:nvPr>
+            <p:ph type="sldNum" sz="quarter" idx="10"/>
+          </p:nvPr>
+        </p:nvSpPr>
+        <p:spPr/>
+        <p:txBody>
+          <a:bodyPr/>
+          <a:lstStyle/>
+          <a:p>
+            <a:fld id="{F7021451-1387-4CA6-816F-3879F97B5CBC}" type="slidenum">
+              <a:rPr lang="en-US"/>
+              <a:t>11</a:t>
             </a:fld>
             <a:endParaRPr lang="en-US"/>
           </a:p>
@@ -2347,6 +2436,1749 @@
 <file path=ppt/slides/slide10.xml><?xml version="1.0" encoding="utf-8"?>
 <p:sld xmlns:a="http://schemas.openxmlformats.org/drawingml/2006/main" xmlns:r="http://schemas.openxmlformats.org/officeDocument/2006/relationships" xmlns:p="http://schemas.openxmlformats.org/presentationml/2006/main">
   <p:cSld name="Slide 10">
+    <p:bg>
+      <p:bgPr>
+        <a:solidFill>
+          <a:srgbClr val="0F1119"/>
+        </a:solidFill>
+      </p:bgPr>
+    </p:bg>
+    <p:spTree>
+      <p:nvGrpSpPr>
+        <p:cNvPr id="1" name=""/>
+        <p:cNvGrpSpPr/>
+        <p:nvPr/>
+      </p:nvGrpSpPr>
+      <p:grpSpPr>
+        <a:xfrm>
+          <a:off x="0" y="0"/>
+          <a:ext cx="0" cy="0"/>
+          <a:chOff x="0" y="0"/>
+          <a:chExt cx="0" cy="0"/>
+        </a:xfrm>
+      </p:grpSpPr>
+      <p:sp>
+        <p:nvSpPr>
+          <p:cNvPr id="2" name="Text 0"/>
+          <p:cNvSpPr/>
+          <p:nvPr/>
+        </p:nvSpPr>
+        <p:spPr>
+          <a:xfrm>
+            <a:off x="0" y="0"/>
+            <a:ext cx="9144000" cy="38100"/>
+          </a:xfrm>
+          <a:prstGeom prst="rect">
+            <a:avLst/>
+          </a:prstGeom>
+          <a:solidFill>
+            <a:srgbClr val="D4AF37"/>
+          </a:solidFill>
+          <a:ln/>
+        </p:spPr>
+        <p:txBody>
+          <a:bodyPr wrap="square" rtlCol="0" anchor="ctr"/>
+          <a:lstStyle/>
+          <a:p>
+            <a:pPr indent="0" marL="0">
+              <a:buNone/>
+            </a:pPr>
+            <a:endParaRPr lang="en-US" dirty="0"/>
+          </a:p>
+        </p:txBody>
+      </p:sp>
+      <p:sp>
+        <p:nvSpPr>
+          <p:cNvPr id="3" name="Text 1"/>
+          <p:cNvSpPr/>
+          <p:nvPr/>
+        </p:nvSpPr>
+        <p:spPr>
+          <a:xfrm>
+            <a:off x="381000" y="190500"/>
+            <a:ext cx="1037130" cy="209550"/>
+          </a:xfrm>
+          <a:prstGeom prst="rect">
+            <a:avLst/>
+          </a:prstGeom>
+          <a:noFill/>
+          <a:ln/>
+        </p:spPr>
+        <p:txBody>
+          <a:bodyPr wrap="square" lIns="0" tIns="0" rIns="0" bIns="0" rtlCol="0" anchor="t"/>
+          <a:lstStyle/>
+          <a:p>
+            <a:pPr algn="l" indent="0" marL="0">
+              <a:buNone/>
+            </a:pPr>
+            <a:r>
+              <a:rPr lang="en-US" sz="1400" b="1" dirty="0">
+                <a:solidFill>
+                  <a:srgbClr val="D4AF37"/>
+                </a:solidFill>
+                <a:latin typeface="Arial" pitchFamily="34" charset="0"/>
+                <a:ea typeface="Arial" pitchFamily="34" charset="-122"/>
+                <a:cs typeface="Arial" pitchFamily="34" charset="-120"/>
+              </a:rPr>
+              <a:t>FLOWDESK</a:t>
+            </a:r>
+            <a:endParaRPr lang="en-US" sz="1400" dirty="0"/>
+          </a:p>
+        </p:txBody>
+      </p:sp>
+      <p:sp>
+        <p:nvSpPr>
+          <p:cNvPr id="4" name="Text 2"/>
+          <p:cNvSpPr/>
+          <p:nvPr/>
+        </p:nvSpPr>
+        <p:spPr>
+          <a:xfrm>
+            <a:off x="7650956" y="228600"/>
+            <a:ext cx="1134285" cy="133350"/>
+          </a:xfrm>
+          <a:prstGeom prst="rect">
+            <a:avLst/>
+          </a:prstGeom>
+          <a:noFill/>
+          <a:ln/>
+        </p:spPr>
+        <p:txBody>
+          <a:bodyPr wrap="square" lIns="0" tIns="0" rIns="0" bIns="0" rtlCol="0" anchor="t"/>
+          <a:lstStyle/>
+          <a:p>
+            <a:pPr algn="l" indent="0" marL="0">
+              <a:buNone/>
+            </a:pPr>
+            <a:r>
+              <a:rPr lang="en-US" sz="900" dirty="0">
+                <a:solidFill>
+                  <a:srgbClr val="9CA3AF"/>
+                </a:solidFill>
+                <a:latin typeface="Arial" pitchFamily="34" charset="0"/>
+                <a:ea typeface="Arial" pitchFamily="34" charset="-122"/>
+                <a:cs typeface="Arial" pitchFamily="34" charset="-120"/>
+              </a:rPr>
+              <a:t>Campaign Dashboard</a:t>
+            </a:r>
+            <a:endParaRPr lang="en-US" sz="900" dirty="0"/>
+          </a:p>
+        </p:txBody>
+      </p:sp>
+      <p:sp>
+        <p:nvSpPr>
+          <p:cNvPr id="5" name="Text 3"/>
+          <p:cNvSpPr/>
+          <p:nvPr/>
+        </p:nvSpPr>
+        <p:spPr>
+          <a:xfrm>
+            <a:off x="381000" y="501551"/>
+            <a:ext cx="8549640" cy="238125"/>
+          </a:xfrm>
+          <a:prstGeom prst="rect">
+            <a:avLst/>
+          </a:prstGeom>
+          <a:noFill/>
+          <a:ln/>
+        </p:spPr>
+        <p:txBody>
+          <a:bodyPr wrap="square" lIns="0" tIns="0" rIns="0" bIns="0" rtlCol="0" anchor="t"/>
+          <a:lstStyle/>
+          <a:p>
+            <a:pPr algn="l" indent="0" marL="0">
+              <a:spcBef>
+                <a:spcPts val="200"/>
+              </a:spcBef>
+              <a:spcAft>
+                <a:spcPts val="300"/>
+              </a:spcAft>
+              <a:buNone/>
+            </a:pPr>
+            <a:r>
+              <a:rPr lang="en-US" sz="1600" b="1" dirty="0">
+                <a:solidFill>
+                  <a:srgbClr val="F1F1F1"/>
+                </a:solidFill>
+                <a:latin typeface="Arial" pitchFamily="34" charset="0"/>
+                <a:ea typeface="Arial" pitchFamily="34" charset="-122"/>
+                <a:cs typeface="Arial" pitchFamily="34" charset="-120"/>
+              </a:rPr>
+              <a:t>Campaign Analytics Dashboard</a:t>
+            </a:r>
+            <a:endParaRPr lang="en-US" sz="1600" dirty="0"/>
+          </a:p>
+        </p:txBody>
+      </p:sp>
+      <p:sp>
+        <p:nvSpPr>
+          <p:cNvPr id="6" name="Text 4"/>
+          <p:cNvSpPr/>
+          <p:nvPr/>
+        </p:nvSpPr>
+        <p:spPr>
+          <a:xfrm>
+            <a:off x="381000" y="777776"/>
+            <a:ext cx="8549640" cy="114300"/>
+          </a:xfrm>
+          <a:prstGeom prst="rect">
+            <a:avLst/>
+          </a:prstGeom>
+          <a:noFill/>
+          <a:ln/>
+        </p:spPr>
+        <p:txBody>
+          <a:bodyPr wrap="square" lIns="0" tIns="0" rIns="0" bIns="0" rtlCol="0" anchor="t"/>
+          <a:lstStyle/>
+          <a:p>
+            <a:pPr algn="l" indent="0" marL="0">
+              <a:spcAft>
+                <a:spcPts val="800"/>
+              </a:spcAft>
+              <a:buNone/>
+            </a:pPr>
+            <a:r>
+              <a:rPr lang="en-US" sz="800" dirty="0">
+                <a:solidFill>
+                  <a:srgbClr val="9CA3AF"/>
+                </a:solidFill>
+                <a:latin typeface="Arial" pitchFamily="34" charset="0"/>
+                <a:ea typeface="Arial" pitchFamily="34" charset="-122"/>
+                <a:cs typeface="Arial" pitchFamily="34" charset="-120"/>
+              </a:rPr>
+              <a:t>Real-time insights across all your Telegram campaigns</a:t>
+            </a:r>
+            <a:endParaRPr lang="en-US" sz="800" dirty="0"/>
+          </a:p>
+        </p:txBody>
+      </p:sp>
+      <p:sp>
+        <p:nvSpPr>
+          <p:cNvPr id="7" name="Text 5"/>
+          <p:cNvSpPr/>
+          <p:nvPr/>
+        </p:nvSpPr>
+        <p:spPr>
+          <a:xfrm>
+            <a:off x="381000" y="993577"/>
+            <a:ext cx="2019300" cy="729853"/>
+          </a:xfrm>
+          <a:prstGeom prst="roundRect">
+            <a:avLst>
+              <a:gd name="adj" fmla="val 8700"/>
+            </a:avLst>
+          </a:prstGeom>
+          <a:solidFill>
+            <a:srgbClr val="1A1D2E"/>
+          </a:solidFill>
+          <a:ln w="9525">
+            <a:solidFill>
+              <a:srgbClr val="2A2D3E"/>
+            </a:solidFill>
+          </a:ln>
+        </p:spPr>
+        <p:txBody>
+          <a:bodyPr wrap="square" rtlCol="0" anchor="ctr"/>
+          <a:lstStyle/>
+          <a:p>
+            <a:pPr indent="0" marL="0">
+              <a:buNone/>
+            </a:pPr>
+            <a:endParaRPr lang="en-US" dirty="0"/>
+          </a:p>
+        </p:txBody>
+      </p:sp>
+      <p:sp>
+        <p:nvSpPr>
+          <p:cNvPr id="8" name="Text 6"/>
+          <p:cNvSpPr/>
+          <p:nvPr/>
+        </p:nvSpPr>
+        <p:spPr>
+          <a:xfrm>
+            <a:off x="500012" y="1104602"/>
+            <a:ext cx="1781276" cy="266700"/>
+          </a:xfrm>
+          <a:prstGeom prst="rect">
+            <a:avLst/>
+          </a:prstGeom>
+          <a:noFill/>
+          <a:ln/>
+        </p:spPr>
+        <p:txBody>
+          <a:bodyPr wrap="square" lIns="0" tIns="0" rIns="0" bIns="0" rtlCol="0" anchor="t"/>
+          <a:lstStyle/>
+          <a:p>
+            <a:pPr algn="ctr" indent="0" marL="0">
+              <a:buNone/>
+            </a:pPr>
+            <a:r>
+              <a:rPr lang="en-US" sz="1800" b="1" dirty="0">
+                <a:solidFill>
+                  <a:srgbClr val="F1F1F1"/>
+                </a:solidFill>
+                <a:latin typeface="Arial" pitchFamily="34" charset="0"/>
+                <a:ea typeface="Arial" pitchFamily="34" charset="-122"/>
+                <a:cs typeface="Arial" pitchFamily="34" charset="-120"/>
+              </a:rPr>
+              <a:t>12,847</a:t>
+            </a:r>
+            <a:endParaRPr lang="en-US" sz="1800" dirty="0"/>
+          </a:p>
+        </p:txBody>
+      </p:sp>
+      <p:sp>
+        <p:nvSpPr>
+          <p:cNvPr id="9" name="Text 7"/>
+          <p:cNvSpPr/>
+          <p:nvPr/>
+        </p:nvSpPr>
+        <p:spPr>
+          <a:xfrm>
+            <a:off x="500012" y="1396603"/>
+            <a:ext cx="1781276" cy="95250"/>
+          </a:xfrm>
+          <a:prstGeom prst="rect">
+            <a:avLst/>
+          </a:prstGeom>
+          <a:noFill/>
+          <a:ln/>
+        </p:spPr>
+        <p:txBody>
+          <a:bodyPr wrap="square" lIns="0" tIns="0" rIns="0" bIns="0" rtlCol="0" anchor="t"/>
+          <a:lstStyle/>
+          <a:p>
+            <a:pPr algn="ctr" indent="0" marL="0">
+              <a:spcBef>
+                <a:spcPts val="200"/>
+              </a:spcBef>
+              <a:buNone/>
+            </a:pPr>
+            <a:r>
+              <a:rPr lang="en-US" sz="700" dirty="0">
+                <a:solidFill>
+                  <a:srgbClr val="9CA3AF"/>
+                </a:solidFill>
+                <a:latin typeface="Arial" pitchFamily="34" charset="0"/>
+                <a:ea typeface="Arial" pitchFamily="34" charset="-122"/>
+                <a:cs typeface="Arial" pitchFamily="34" charset="-120"/>
+              </a:rPr>
+              <a:t>Messages Sent</a:t>
+            </a:r>
+            <a:endParaRPr lang="en-US" sz="700" dirty="0"/>
+          </a:p>
+        </p:txBody>
+      </p:sp>
+      <p:sp>
+        <p:nvSpPr>
+          <p:cNvPr id="10" name="Text 8"/>
+          <p:cNvSpPr/>
+          <p:nvPr/>
+        </p:nvSpPr>
+        <p:spPr>
+          <a:xfrm>
+            <a:off x="500012" y="1517154"/>
+            <a:ext cx="1781276" cy="95250"/>
+          </a:xfrm>
+          <a:prstGeom prst="rect">
+            <a:avLst/>
+          </a:prstGeom>
+          <a:noFill/>
+          <a:ln/>
+        </p:spPr>
+        <p:txBody>
+          <a:bodyPr wrap="square" lIns="0" tIns="0" rIns="0" bIns="0" rtlCol="0" anchor="t"/>
+          <a:lstStyle/>
+          <a:p>
+            <a:pPr algn="ctr" indent="0" marL="0">
+              <a:spcBef>
+                <a:spcPts val="200"/>
+              </a:spcBef>
+              <a:buNone/>
+            </a:pPr>
+            <a:r>
+              <a:rPr lang="en-US" sz="700" dirty="0">
+                <a:solidFill>
+                  <a:srgbClr val="10B981"/>
+                </a:solidFill>
+                <a:latin typeface="Arial" pitchFamily="34" charset="0"/>
+                <a:ea typeface="Arial" pitchFamily="34" charset="-122"/>
+                <a:cs typeface="Arial" pitchFamily="34" charset="-120"/>
+              </a:rPr>
+              <a:t>+23% this week</a:t>
+            </a:r>
+            <a:endParaRPr lang="en-US" sz="700" dirty="0"/>
+          </a:p>
+        </p:txBody>
+      </p:sp>
+      <p:sp>
+        <p:nvSpPr>
+          <p:cNvPr id="11" name="Text 9"/>
+          <p:cNvSpPr/>
+          <p:nvPr/>
+        </p:nvSpPr>
+        <p:spPr>
+          <a:xfrm>
+            <a:off x="2501801" y="993577"/>
+            <a:ext cx="2019449" cy="729853"/>
+          </a:xfrm>
+          <a:prstGeom prst="roundRect">
+            <a:avLst>
+              <a:gd name="adj" fmla="val 8700"/>
+            </a:avLst>
+          </a:prstGeom>
+          <a:solidFill>
+            <a:srgbClr val="1A1D2E"/>
+          </a:solidFill>
+          <a:ln w="9525">
+            <a:solidFill>
+              <a:srgbClr val="2A2D3E"/>
+            </a:solidFill>
+          </a:ln>
+        </p:spPr>
+        <p:txBody>
+          <a:bodyPr wrap="square" rtlCol="0" anchor="ctr"/>
+          <a:lstStyle/>
+          <a:p>
+            <a:pPr indent="0" marL="0">
+              <a:buNone/>
+            </a:pPr>
+            <a:endParaRPr lang="en-US" dirty="0"/>
+          </a:p>
+        </p:txBody>
+      </p:sp>
+      <p:sp>
+        <p:nvSpPr>
+          <p:cNvPr id="12" name="Text 10"/>
+          <p:cNvSpPr/>
+          <p:nvPr/>
+        </p:nvSpPr>
+        <p:spPr>
+          <a:xfrm>
+            <a:off x="2620811" y="1104602"/>
+            <a:ext cx="1781428" cy="266700"/>
+          </a:xfrm>
+          <a:prstGeom prst="rect">
+            <a:avLst/>
+          </a:prstGeom>
+          <a:noFill/>
+          <a:ln/>
+        </p:spPr>
+        <p:txBody>
+          <a:bodyPr wrap="square" lIns="0" tIns="0" rIns="0" bIns="0" rtlCol="0" anchor="t"/>
+          <a:lstStyle/>
+          <a:p>
+            <a:pPr algn="ctr" indent="0" marL="0">
+              <a:buNone/>
+            </a:pPr>
+            <a:r>
+              <a:rPr lang="en-US" sz="1800" b="1" dirty="0">
+                <a:solidFill>
+                  <a:srgbClr val="F1F1F1"/>
+                </a:solidFill>
+                <a:latin typeface="Arial" pitchFamily="34" charset="0"/>
+                <a:ea typeface="Arial" pitchFamily="34" charset="-122"/>
+                <a:cs typeface="Arial" pitchFamily="34" charset="-120"/>
+              </a:rPr>
+              <a:t>94.2%</a:t>
+            </a:r>
+            <a:endParaRPr lang="en-US" sz="1800" dirty="0"/>
+          </a:p>
+        </p:txBody>
+      </p:sp>
+      <p:sp>
+        <p:nvSpPr>
+          <p:cNvPr id="13" name="Text 11"/>
+          <p:cNvSpPr/>
+          <p:nvPr/>
+        </p:nvSpPr>
+        <p:spPr>
+          <a:xfrm>
+            <a:off x="2620811" y="1396603"/>
+            <a:ext cx="1781428" cy="95250"/>
+          </a:xfrm>
+          <a:prstGeom prst="rect">
+            <a:avLst/>
+          </a:prstGeom>
+          <a:noFill/>
+          <a:ln/>
+        </p:spPr>
+        <p:txBody>
+          <a:bodyPr wrap="square" lIns="0" tIns="0" rIns="0" bIns="0" rtlCol="0" anchor="t"/>
+          <a:lstStyle/>
+          <a:p>
+            <a:pPr algn="ctr" indent="0" marL="0">
+              <a:spcBef>
+                <a:spcPts val="200"/>
+              </a:spcBef>
+              <a:buNone/>
+            </a:pPr>
+            <a:r>
+              <a:rPr lang="en-US" sz="700" dirty="0">
+                <a:solidFill>
+                  <a:srgbClr val="9CA3AF"/>
+                </a:solidFill>
+                <a:latin typeface="Arial" pitchFamily="34" charset="0"/>
+                <a:ea typeface="Arial" pitchFamily="34" charset="-122"/>
+                <a:cs typeface="Arial" pitchFamily="34" charset="-120"/>
+              </a:rPr>
+              <a:t>Delivery Rate</a:t>
+            </a:r>
+            <a:endParaRPr lang="en-US" sz="700" dirty="0"/>
+          </a:p>
+        </p:txBody>
+      </p:sp>
+      <p:sp>
+        <p:nvSpPr>
+          <p:cNvPr id="14" name="Text 12"/>
+          <p:cNvSpPr/>
+          <p:nvPr/>
+        </p:nvSpPr>
+        <p:spPr>
+          <a:xfrm>
+            <a:off x="2620811" y="1517154"/>
+            <a:ext cx="1781428" cy="95250"/>
+          </a:xfrm>
+          <a:prstGeom prst="rect">
+            <a:avLst/>
+          </a:prstGeom>
+          <a:noFill/>
+          <a:ln/>
+        </p:spPr>
+        <p:txBody>
+          <a:bodyPr wrap="square" lIns="0" tIns="0" rIns="0" bIns="0" rtlCol="0" anchor="t"/>
+          <a:lstStyle/>
+          <a:p>
+            <a:pPr algn="ctr" indent="0" marL="0">
+              <a:spcBef>
+                <a:spcPts val="200"/>
+              </a:spcBef>
+              <a:buNone/>
+            </a:pPr>
+            <a:r>
+              <a:rPr lang="en-US" sz="700" dirty="0">
+                <a:solidFill>
+                  <a:srgbClr val="10B981"/>
+                </a:solidFill>
+                <a:latin typeface="Arial" pitchFamily="34" charset="0"/>
+                <a:ea typeface="Arial" pitchFamily="34" charset="-122"/>
+                <a:cs typeface="Arial" pitchFamily="34" charset="-120"/>
+              </a:rPr>
+              <a:t>+1.3% vs last</a:t>
+            </a:r>
+            <a:endParaRPr lang="en-US" sz="700" dirty="0"/>
+          </a:p>
+        </p:txBody>
+      </p:sp>
+      <p:sp>
+        <p:nvSpPr>
+          <p:cNvPr id="15" name="Text 13"/>
+          <p:cNvSpPr/>
+          <p:nvPr/>
+        </p:nvSpPr>
+        <p:spPr>
+          <a:xfrm>
+            <a:off x="4622750" y="993577"/>
+            <a:ext cx="2019300" cy="729853"/>
+          </a:xfrm>
+          <a:prstGeom prst="roundRect">
+            <a:avLst>
+              <a:gd name="adj" fmla="val 8700"/>
+            </a:avLst>
+          </a:prstGeom>
+          <a:solidFill>
+            <a:srgbClr val="1A1D2E"/>
+          </a:solidFill>
+          <a:ln w="9525">
+            <a:solidFill>
+              <a:srgbClr val="2A2D3E"/>
+            </a:solidFill>
+          </a:ln>
+        </p:spPr>
+        <p:txBody>
+          <a:bodyPr wrap="square" rtlCol="0" anchor="ctr"/>
+          <a:lstStyle/>
+          <a:p>
+            <a:pPr indent="0" marL="0">
+              <a:buNone/>
+            </a:pPr>
+            <a:endParaRPr lang="en-US" dirty="0"/>
+          </a:p>
+        </p:txBody>
+      </p:sp>
+      <p:sp>
+        <p:nvSpPr>
+          <p:cNvPr id="16" name="Text 14"/>
+          <p:cNvSpPr/>
+          <p:nvPr/>
+        </p:nvSpPr>
+        <p:spPr>
+          <a:xfrm>
+            <a:off x="4741762" y="1104602"/>
+            <a:ext cx="1781276" cy="266700"/>
+          </a:xfrm>
+          <a:prstGeom prst="rect">
+            <a:avLst/>
+          </a:prstGeom>
+          <a:noFill/>
+          <a:ln/>
+        </p:spPr>
+        <p:txBody>
+          <a:bodyPr wrap="square" lIns="0" tIns="0" rIns="0" bIns="0" rtlCol="0" anchor="t"/>
+          <a:lstStyle/>
+          <a:p>
+            <a:pPr algn="ctr" indent="0" marL="0">
+              <a:buNone/>
+            </a:pPr>
+            <a:r>
+              <a:rPr lang="en-US" sz="1800" b="1" dirty="0">
+                <a:solidFill>
+                  <a:srgbClr val="F1F1F1"/>
+                </a:solidFill>
+                <a:latin typeface="Arial" pitchFamily="34" charset="0"/>
+                <a:ea typeface="Arial" pitchFamily="34" charset="-122"/>
+                <a:cs typeface="Arial" pitchFamily="34" charset="-120"/>
+              </a:rPr>
+              <a:t>78.6%</a:t>
+            </a:r>
+            <a:endParaRPr lang="en-US" sz="1800" dirty="0"/>
+          </a:p>
+        </p:txBody>
+      </p:sp>
+      <p:sp>
+        <p:nvSpPr>
+          <p:cNvPr id="17" name="Text 15"/>
+          <p:cNvSpPr/>
+          <p:nvPr/>
+        </p:nvSpPr>
+        <p:spPr>
+          <a:xfrm>
+            <a:off x="4741762" y="1396603"/>
+            <a:ext cx="1781276" cy="95250"/>
+          </a:xfrm>
+          <a:prstGeom prst="rect">
+            <a:avLst/>
+          </a:prstGeom>
+          <a:noFill/>
+          <a:ln/>
+        </p:spPr>
+        <p:txBody>
+          <a:bodyPr wrap="square" lIns="0" tIns="0" rIns="0" bIns="0" rtlCol="0" anchor="t"/>
+          <a:lstStyle/>
+          <a:p>
+            <a:pPr algn="ctr" indent="0" marL="0">
+              <a:spcBef>
+                <a:spcPts val="200"/>
+              </a:spcBef>
+              <a:buNone/>
+            </a:pPr>
+            <a:r>
+              <a:rPr lang="en-US" sz="700" dirty="0">
+                <a:solidFill>
+                  <a:srgbClr val="9CA3AF"/>
+                </a:solidFill>
+                <a:latin typeface="Arial" pitchFamily="34" charset="0"/>
+                <a:ea typeface="Arial" pitchFamily="34" charset="-122"/>
+                <a:cs typeface="Arial" pitchFamily="34" charset="-120"/>
+              </a:rPr>
+              <a:t>Open Rate</a:t>
+            </a:r>
+            <a:endParaRPr lang="en-US" sz="700" dirty="0"/>
+          </a:p>
+        </p:txBody>
+      </p:sp>
+      <p:sp>
+        <p:nvSpPr>
+          <p:cNvPr id="18" name="Text 16"/>
+          <p:cNvSpPr/>
+          <p:nvPr/>
+        </p:nvSpPr>
+        <p:spPr>
+          <a:xfrm>
+            <a:off x="4741762" y="1517154"/>
+            <a:ext cx="1781276" cy="95250"/>
+          </a:xfrm>
+          <a:prstGeom prst="rect">
+            <a:avLst/>
+          </a:prstGeom>
+          <a:noFill/>
+          <a:ln/>
+        </p:spPr>
+        <p:txBody>
+          <a:bodyPr wrap="square" lIns="0" tIns="0" rIns="0" bIns="0" rtlCol="0" anchor="t"/>
+          <a:lstStyle/>
+          <a:p>
+            <a:pPr algn="ctr" indent="0" marL="0">
+              <a:spcBef>
+                <a:spcPts val="200"/>
+              </a:spcBef>
+              <a:buNone/>
+            </a:pPr>
+            <a:r>
+              <a:rPr lang="en-US" sz="700" dirty="0">
+                <a:solidFill>
+                  <a:srgbClr val="10B981"/>
+                </a:solidFill>
+                <a:latin typeface="Arial" pitchFamily="34" charset="0"/>
+                <a:ea typeface="Arial" pitchFamily="34" charset="-122"/>
+                <a:cs typeface="Arial" pitchFamily="34" charset="-120"/>
+              </a:rPr>
+              <a:t>+5.2% vs email</a:t>
+            </a:r>
+            <a:endParaRPr lang="en-US" sz="700" dirty="0"/>
+          </a:p>
+        </p:txBody>
+      </p:sp>
+      <p:sp>
+        <p:nvSpPr>
+          <p:cNvPr id="19" name="Text 17"/>
+          <p:cNvSpPr/>
+          <p:nvPr/>
+        </p:nvSpPr>
+        <p:spPr>
+          <a:xfrm>
+            <a:off x="6743551" y="993577"/>
+            <a:ext cx="2019449" cy="729853"/>
+          </a:xfrm>
+          <a:prstGeom prst="roundRect">
+            <a:avLst>
+              <a:gd name="adj" fmla="val 8700"/>
+            </a:avLst>
+          </a:prstGeom>
+          <a:solidFill>
+            <a:srgbClr val="1A1D2E"/>
+          </a:solidFill>
+          <a:ln w="9525">
+            <a:solidFill>
+              <a:srgbClr val="2A2D3E"/>
+            </a:solidFill>
+          </a:ln>
+        </p:spPr>
+        <p:txBody>
+          <a:bodyPr wrap="square" rtlCol="0" anchor="ctr"/>
+          <a:lstStyle/>
+          <a:p>
+            <a:pPr indent="0" marL="0">
+              <a:buNone/>
+            </a:pPr>
+            <a:endParaRPr lang="en-US" dirty="0"/>
+          </a:p>
+        </p:txBody>
+      </p:sp>
+      <p:sp>
+        <p:nvSpPr>
+          <p:cNvPr id="20" name="Text 18"/>
+          <p:cNvSpPr/>
+          <p:nvPr/>
+        </p:nvSpPr>
+        <p:spPr>
+          <a:xfrm>
+            <a:off x="6862562" y="1104602"/>
+            <a:ext cx="1781428" cy="266700"/>
+          </a:xfrm>
+          <a:prstGeom prst="rect">
+            <a:avLst/>
+          </a:prstGeom>
+          <a:noFill/>
+          <a:ln/>
+        </p:spPr>
+        <p:txBody>
+          <a:bodyPr wrap="square" lIns="0" tIns="0" rIns="0" bIns="0" rtlCol="0" anchor="t"/>
+          <a:lstStyle/>
+          <a:p>
+            <a:pPr algn="ctr" indent="0" marL="0">
+              <a:buNone/>
+            </a:pPr>
+            <a:r>
+              <a:rPr lang="en-US" sz="1800" b="1" dirty="0">
+                <a:solidFill>
+                  <a:srgbClr val="D4AF37"/>
+                </a:solidFill>
+                <a:latin typeface="Arial" pitchFamily="34" charset="0"/>
+                <a:ea typeface="Arial" pitchFamily="34" charset="-122"/>
+                <a:cs typeface="Arial" pitchFamily="34" charset="-120"/>
+              </a:rPr>
+              <a:t>$48.2K</a:t>
+            </a:r>
+            <a:endParaRPr lang="en-US" sz="1800" dirty="0"/>
+          </a:p>
+        </p:txBody>
+      </p:sp>
+      <p:sp>
+        <p:nvSpPr>
+          <p:cNvPr id="21" name="Text 19"/>
+          <p:cNvSpPr/>
+          <p:nvPr/>
+        </p:nvSpPr>
+        <p:spPr>
+          <a:xfrm>
+            <a:off x="6862562" y="1396603"/>
+            <a:ext cx="1781428" cy="95250"/>
+          </a:xfrm>
+          <a:prstGeom prst="rect">
+            <a:avLst/>
+          </a:prstGeom>
+          <a:noFill/>
+          <a:ln/>
+        </p:spPr>
+        <p:txBody>
+          <a:bodyPr wrap="square" lIns="0" tIns="0" rIns="0" bIns="0" rtlCol="0" anchor="t"/>
+          <a:lstStyle/>
+          <a:p>
+            <a:pPr algn="ctr" indent="0" marL="0">
+              <a:spcBef>
+                <a:spcPts val="200"/>
+              </a:spcBef>
+              <a:buNone/>
+            </a:pPr>
+            <a:r>
+              <a:rPr lang="en-US" sz="700" dirty="0">
+                <a:solidFill>
+                  <a:srgbClr val="9CA3AF"/>
+                </a:solidFill>
+                <a:latin typeface="Arial" pitchFamily="34" charset="0"/>
+                <a:ea typeface="Arial" pitchFamily="34" charset="-122"/>
+                <a:cs typeface="Arial" pitchFamily="34" charset="-120"/>
+              </a:rPr>
+              <a:t>Revenue Attributed</a:t>
+            </a:r>
+            <a:endParaRPr lang="en-US" sz="700" dirty="0"/>
+          </a:p>
+        </p:txBody>
+      </p:sp>
+      <p:sp>
+        <p:nvSpPr>
+          <p:cNvPr id="22" name="Text 20"/>
+          <p:cNvSpPr/>
+          <p:nvPr/>
+        </p:nvSpPr>
+        <p:spPr>
+          <a:xfrm>
+            <a:off x="6862562" y="1517154"/>
+            <a:ext cx="1781428" cy="95250"/>
+          </a:xfrm>
+          <a:prstGeom prst="rect">
+            <a:avLst/>
+          </a:prstGeom>
+          <a:noFill/>
+          <a:ln/>
+        </p:spPr>
+        <p:txBody>
+          <a:bodyPr wrap="square" lIns="0" tIns="0" rIns="0" bIns="0" rtlCol="0" anchor="t"/>
+          <a:lstStyle/>
+          <a:p>
+            <a:pPr algn="ctr" indent="0" marL="0">
+              <a:spcBef>
+                <a:spcPts val="200"/>
+              </a:spcBef>
+              <a:buNone/>
+            </a:pPr>
+            <a:r>
+              <a:rPr lang="en-US" sz="700" dirty="0">
+                <a:solidFill>
+                  <a:srgbClr val="10B981"/>
+                </a:solidFill>
+                <a:latin typeface="Arial" pitchFamily="34" charset="0"/>
+                <a:ea typeface="Arial" pitchFamily="34" charset="-122"/>
+                <a:cs typeface="Arial" pitchFamily="34" charset="-120"/>
+              </a:rPr>
+              <a:t>+31% ROI</a:t>
+            </a:r>
+            <a:endParaRPr lang="en-US" sz="700" dirty="0"/>
+          </a:p>
+        </p:txBody>
+      </p:sp>
+      <p:sp>
+        <p:nvSpPr>
+          <p:cNvPr id="23" name="Text 21"/>
+          <p:cNvSpPr/>
+          <p:nvPr/>
+        </p:nvSpPr>
+        <p:spPr>
+          <a:xfrm>
+            <a:off x="381000" y="1824930"/>
+            <a:ext cx="3271540" cy="1501080"/>
+          </a:xfrm>
+          <a:prstGeom prst="roundRect">
+            <a:avLst>
+              <a:gd name="adj" fmla="val 4230"/>
+            </a:avLst>
+          </a:prstGeom>
+          <a:solidFill>
+            <a:srgbClr val="1A1D2E"/>
+          </a:solidFill>
+          <a:ln w="9525">
+            <a:solidFill>
+              <a:srgbClr val="2A2D3E"/>
+            </a:solidFill>
+          </a:ln>
+        </p:spPr>
+        <p:txBody>
+          <a:bodyPr wrap="square" rtlCol="0" anchor="ctr"/>
+          <a:lstStyle/>
+          <a:p>
+            <a:pPr indent="0" marL="0">
+              <a:buNone/>
+            </a:pPr>
+            <a:endParaRPr lang="en-US" dirty="0"/>
+          </a:p>
+        </p:txBody>
+      </p:sp>
+      <p:sp>
+        <p:nvSpPr>
+          <p:cNvPr id="24" name="Text 22"/>
+          <p:cNvSpPr/>
+          <p:nvPr/>
+        </p:nvSpPr>
+        <p:spPr>
+          <a:xfrm>
+            <a:off x="517475" y="1935956"/>
+            <a:ext cx="3058561" cy="133350"/>
+          </a:xfrm>
+          <a:prstGeom prst="rect">
+            <a:avLst/>
+          </a:prstGeom>
+          <a:noFill/>
+          <a:ln/>
+        </p:spPr>
+        <p:txBody>
+          <a:bodyPr wrap="square" lIns="0" tIns="0" rIns="0" bIns="0" rtlCol="0" anchor="t"/>
+          <a:lstStyle/>
+          <a:p>
+            <a:pPr algn="l" indent="0" marL="0">
+              <a:spcAft>
+                <a:spcPts val="600"/>
+              </a:spcAft>
+              <a:buNone/>
+            </a:pPr>
+            <a:r>
+              <a:rPr lang="en-US" sz="900" b="1" dirty="0">
+                <a:solidFill>
+                  <a:srgbClr val="F1F1F1"/>
+                </a:solidFill>
+                <a:latin typeface="Arial" pitchFamily="34" charset="0"/>
+                <a:ea typeface="Arial" pitchFamily="34" charset="-122"/>
+                <a:cs typeface="Arial" pitchFamily="34" charset="-120"/>
+              </a:rPr>
+              <a:t>Top Campaigns</a:t>
+            </a:r>
+            <a:endParaRPr lang="en-US" sz="900" dirty="0"/>
+          </a:p>
+        </p:txBody>
+      </p:sp>
+      <p:sp>
+        <p:nvSpPr>
+          <p:cNvPr id="25" name="Shape 23"/>
+          <p:cNvSpPr/>
+          <p:nvPr/>
+        </p:nvSpPr>
+        <p:spPr>
+          <a:xfrm>
+            <a:off x="517475" y="2356545"/>
+            <a:ext cx="2998589" cy="0"/>
+          </a:xfrm>
+          <a:prstGeom prst="line">
+            <a:avLst/>
+          </a:prstGeom>
+          <a:noFill/>
+          <a:ln w="9525">
+            <a:solidFill>
+              <a:srgbClr val="2A2D3E"/>
+            </a:solidFill>
+            <a:prstDash val="solid"/>
+          </a:ln>
+        </p:spPr>
+      </p:sp>
+      <p:sp>
+        <p:nvSpPr>
+          <p:cNvPr id="26" name="Shape 24"/>
+          <p:cNvSpPr/>
+          <p:nvPr/>
+        </p:nvSpPr>
+        <p:spPr>
+          <a:xfrm>
+            <a:off x="517475" y="2572345"/>
+            <a:ext cx="2998589" cy="0"/>
+          </a:xfrm>
+          <a:prstGeom prst="line">
+            <a:avLst/>
+          </a:prstGeom>
+          <a:noFill/>
+          <a:ln w="9525">
+            <a:solidFill>
+              <a:srgbClr val="2A2D3E"/>
+            </a:solidFill>
+            <a:prstDash val="solid"/>
+          </a:ln>
+        </p:spPr>
+      </p:sp>
+      <p:sp>
+        <p:nvSpPr>
+          <p:cNvPr id="27" name="Shape 25"/>
+          <p:cNvSpPr/>
+          <p:nvPr/>
+        </p:nvSpPr>
+        <p:spPr>
+          <a:xfrm>
+            <a:off x="517475" y="2788146"/>
+            <a:ext cx="2998589" cy="0"/>
+          </a:xfrm>
+          <a:prstGeom prst="line">
+            <a:avLst/>
+          </a:prstGeom>
+          <a:noFill/>
+          <a:ln w="9525">
+            <a:solidFill>
+              <a:srgbClr val="2A2D3E"/>
+            </a:solidFill>
+            <a:prstDash val="solid"/>
+          </a:ln>
+        </p:spPr>
+      </p:sp>
+      <p:sp>
+        <p:nvSpPr>
+          <p:cNvPr id="28" name="Shape 26"/>
+          <p:cNvSpPr/>
+          <p:nvPr/>
+        </p:nvSpPr>
+        <p:spPr>
+          <a:xfrm>
+            <a:off x="517475" y="3003947"/>
+            <a:ext cx="2998589" cy="0"/>
+          </a:xfrm>
+          <a:prstGeom prst="line">
+            <a:avLst/>
+          </a:prstGeom>
+          <a:noFill/>
+          <a:ln w="9525">
+            <a:solidFill>
+              <a:srgbClr val="2A2D3E"/>
+            </a:solidFill>
+            <a:prstDash val="solid"/>
+          </a:ln>
+        </p:spPr>
+      </p:sp>
+      <p:sp>
+        <p:nvSpPr>
+          <p:cNvPr id="29" name="Text 27"/>
+          <p:cNvSpPr/>
+          <p:nvPr/>
+        </p:nvSpPr>
+        <p:spPr>
+          <a:xfrm>
+            <a:off x="3754041" y="1824930"/>
+            <a:ext cx="2181076" cy="1501080"/>
+          </a:xfrm>
+          <a:prstGeom prst="roundRect">
+            <a:avLst>
+              <a:gd name="adj" fmla="val 4230"/>
+            </a:avLst>
+          </a:prstGeom>
+          <a:solidFill>
+            <a:srgbClr val="1A1D2E"/>
+          </a:solidFill>
+          <a:ln w="9525">
+            <a:solidFill>
+              <a:srgbClr val="2A2D3E"/>
+            </a:solidFill>
+          </a:ln>
+        </p:spPr>
+        <p:txBody>
+          <a:bodyPr wrap="square" rtlCol="0" anchor="ctr"/>
+          <a:lstStyle/>
+          <a:p>
+            <a:pPr indent="0" marL="0">
+              <a:buNone/>
+            </a:pPr>
+            <a:endParaRPr lang="en-US" dirty="0"/>
+          </a:p>
+        </p:txBody>
+      </p:sp>
+      <p:sp>
+        <p:nvSpPr>
+          <p:cNvPr id="30" name="Text 28"/>
+          <p:cNvSpPr/>
+          <p:nvPr/>
+        </p:nvSpPr>
+        <p:spPr>
+          <a:xfrm>
+            <a:off x="3890516" y="1935956"/>
+            <a:ext cx="1946288" cy="133350"/>
+          </a:xfrm>
+          <a:prstGeom prst="rect">
+            <a:avLst/>
+          </a:prstGeom>
+          <a:noFill/>
+          <a:ln/>
+        </p:spPr>
+        <p:txBody>
+          <a:bodyPr wrap="square" lIns="0" tIns="0" rIns="0" bIns="0" rtlCol="0" anchor="t"/>
+          <a:lstStyle/>
+          <a:p>
+            <a:pPr algn="l" indent="0" marL="0">
+              <a:spcAft>
+                <a:spcPts val="600"/>
+              </a:spcAft>
+              <a:buNone/>
+            </a:pPr>
+            <a:r>
+              <a:rPr lang="en-US" sz="900" b="1" dirty="0">
+                <a:solidFill>
+                  <a:srgbClr val="F1F1F1"/>
+                </a:solidFill>
+                <a:latin typeface="Arial" pitchFamily="34" charset="0"/>
+                <a:ea typeface="Arial" pitchFamily="34" charset="-122"/>
+                <a:cs typeface="Arial" pitchFamily="34" charset="-120"/>
+              </a:rPr>
+              <a:t>VIP Tier Breakdown</a:t>
+            </a:r>
+            <a:endParaRPr lang="en-US" sz="900" dirty="0"/>
+          </a:p>
+        </p:txBody>
+      </p:sp>
+      <p:sp>
+        <p:nvSpPr>
+          <p:cNvPr id="31" name="Text 29"/>
+          <p:cNvSpPr/>
+          <p:nvPr/>
+        </p:nvSpPr>
+        <p:spPr>
+          <a:xfrm>
+            <a:off x="3890516" y="2159794"/>
+            <a:ext cx="76200" cy="76200"/>
+          </a:xfrm>
+          <a:prstGeom prst="roundRect">
+            <a:avLst>
+              <a:gd name="adj" fmla="val 1200000"/>
+            </a:avLst>
+          </a:prstGeom>
+          <a:solidFill>
+            <a:srgbClr val="D4AF37"/>
+          </a:solidFill>
+          <a:ln/>
+        </p:spPr>
+        <p:txBody>
+          <a:bodyPr wrap="square" rtlCol="0" anchor="ctr"/>
+          <a:lstStyle/>
+          <a:p>
+            <a:pPr indent="0" marL="0">
+              <a:buNone/>
+            </a:pPr>
+            <a:endParaRPr lang="en-US" dirty="0"/>
+          </a:p>
+        </p:txBody>
+      </p:sp>
+      <p:sp>
+        <p:nvSpPr>
+          <p:cNvPr id="32" name="Text 30"/>
+          <p:cNvSpPr/>
+          <p:nvPr/>
+        </p:nvSpPr>
+        <p:spPr>
+          <a:xfrm>
+            <a:off x="3890516" y="2315319"/>
+            <a:ext cx="76200" cy="76200"/>
+          </a:xfrm>
+          <a:prstGeom prst="roundRect">
+            <a:avLst>
+              <a:gd name="adj" fmla="val 1200000"/>
+            </a:avLst>
+          </a:prstGeom>
+          <a:solidFill>
+            <a:srgbClr val="C0C0C0"/>
+          </a:solidFill>
+          <a:ln/>
+        </p:spPr>
+        <p:txBody>
+          <a:bodyPr wrap="square" rtlCol="0" anchor="ctr"/>
+          <a:lstStyle/>
+          <a:p>
+            <a:pPr indent="0" marL="0">
+              <a:buNone/>
+            </a:pPr>
+            <a:endParaRPr lang="en-US" dirty="0"/>
+          </a:p>
+        </p:txBody>
+      </p:sp>
+      <p:sp>
+        <p:nvSpPr>
+          <p:cNvPr id="33" name="Text 31"/>
+          <p:cNvSpPr/>
+          <p:nvPr/>
+        </p:nvSpPr>
+        <p:spPr>
+          <a:xfrm>
+            <a:off x="3890516" y="2470845"/>
+            <a:ext cx="76200" cy="76200"/>
+          </a:xfrm>
+          <a:prstGeom prst="roundRect">
+            <a:avLst>
+              <a:gd name="adj" fmla="val 1200000"/>
+            </a:avLst>
+          </a:prstGeom>
+          <a:solidFill>
+            <a:srgbClr val="CD7F32"/>
+          </a:solidFill>
+          <a:ln/>
+        </p:spPr>
+        <p:txBody>
+          <a:bodyPr wrap="square" rtlCol="0" anchor="ctr"/>
+          <a:lstStyle/>
+          <a:p>
+            <a:pPr indent="0" marL="0">
+              <a:buNone/>
+            </a:pPr>
+            <a:endParaRPr lang="en-US" dirty="0"/>
+          </a:p>
+        </p:txBody>
+      </p:sp>
+      <p:sp>
+        <p:nvSpPr>
+          <p:cNvPr id="34" name="Text 32"/>
+          <p:cNvSpPr/>
+          <p:nvPr/>
+        </p:nvSpPr>
+        <p:spPr>
+          <a:xfrm>
+            <a:off x="3890516" y="2626370"/>
+            <a:ext cx="76200" cy="76200"/>
+          </a:xfrm>
+          <a:prstGeom prst="roundRect">
+            <a:avLst>
+              <a:gd name="adj" fmla="val 1200000"/>
+            </a:avLst>
+          </a:prstGeom>
+          <a:solidFill>
+            <a:srgbClr val="6B7280"/>
+          </a:solidFill>
+          <a:ln/>
+        </p:spPr>
+        <p:txBody>
+          <a:bodyPr wrap="square" rtlCol="0" anchor="ctr"/>
+          <a:lstStyle/>
+          <a:p>
+            <a:pPr indent="0" marL="0">
+              <a:buNone/>
+            </a:pPr>
+            <a:endParaRPr lang="en-US" dirty="0"/>
+          </a:p>
+        </p:txBody>
+      </p:sp>
+      <p:sp>
+        <p:nvSpPr>
+          <p:cNvPr id="35" name="Text 33"/>
+          <p:cNvSpPr/>
+          <p:nvPr/>
+        </p:nvSpPr>
+        <p:spPr>
+          <a:xfrm>
+            <a:off x="3890516" y="2793057"/>
+            <a:ext cx="1946288" cy="95250"/>
+          </a:xfrm>
+          <a:prstGeom prst="rect">
+            <a:avLst/>
+          </a:prstGeom>
+          <a:noFill/>
+          <a:ln/>
+        </p:spPr>
+        <p:txBody>
+          <a:bodyPr wrap="square" lIns="0" tIns="0" rIns="0" bIns="0" rtlCol="0" anchor="t"/>
+          <a:lstStyle/>
+          <a:p>
+            <a:pPr algn="l" indent="0" marL="0">
+              <a:spcBef>
+                <a:spcPts val="600"/>
+              </a:spcBef>
+              <a:buNone/>
+            </a:pPr>
+            <a:r>
+              <a:rPr lang="en-US" sz="700" b="1" dirty="0">
+                <a:solidFill>
+                  <a:srgbClr val="D4AF37"/>
+                </a:solidFill>
+                <a:latin typeface="Arial" pitchFamily="34" charset="0"/>
+                <a:ea typeface="Arial" pitchFamily="34" charset="-122"/>
+                <a:cs typeface="Arial" pitchFamily="34" charset="-120"/>
+              </a:rPr>
+              <a:t>1,600 total players</a:t>
+            </a:r>
+            <a:endParaRPr lang="en-US" sz="700" dirty="0"/>
+          </a:p>
+        </p:txBody>
+      </p:sp>
+      <p:sp>
+        <p:nvSpPr>
+          <p:cNvPr id="36" name="Text 34"/>
+          <p:cNvSpPr/>
+          <p:nvPr/>
+        </p:nvSpPr>
+        <p:spPr>
+          <a:xfrm>
+            <a:off x="6036618" y="1824930"/>
+            <a:ext cx="2726382" cy="1501080"/>
+          </a:xfrm>
+          <a:prstGeom prst="roundRect">
+            <a:avLst>
+              <a:gd name="adj" fmla="val 4230"/>
+            </a:avLst>
+          </a:prstGeom>
+          <a:solidFill>
+            <a:srgbClr val="1A1D2E"/>
+          </a:solidFill>
+          <a:ln w="9525">
+            <a:solidFill>
+              <a:srgbClr val="2A2D3E"/>
+            </a:solidFill>
+          </a:ln>
+        </p:spPr>
+        <p:txBody>
+          <a:bodyPr wrap="square" rtlCol="0" anchor="ctr"/>
+          <a:lstStyle/>
+          <a:p>
+            <a:pPr indent="0" marL="0">
+              <a:buNone/>
+            </a:pPr>
+            <a:endParaRPr lang="en-US" dirty="0"/>
+          </a:p>
+        </p:txBody>
+      </p:sp>
+      <p:sp>
+        <p:nvSpPr>
+          <p:cNvPr id="37" name="Text 35"/>
+          <p:cNvSpPr/>
+          <p:nvPr/>
+        </p:nvSpPr>
+        <p:spPr>
+          <a:xfrm>
+            <a:off x="6173093" y="1935956"/>
+            <a:ext cx="2502500" cy="133350"/>
+          </a:xfrm>
+          <a:prstGeom prst="rect">
+            <a:avLst/>
+          </a:prstGeom>
+          <a:noFill/>
+          <a:ln/>
+        </p:spPr>
+        <p:txBody>
+          <a:bodyPr wrap="square" lIns="0" tIns="0" rIns="0" bIns="0" rtlCol="0" anchor="t"/>
+          <a:lstStyle/>
+          <a:p>
+            <a:pPr algn="l" indent="0" marL="0">
+              <a:spcAft>
+                <a:spcPts val="600"/>
+              </a:spcAft>
+              <a:buNone/>
+            </a:pPr>
+            <a:r>
+              <a:rPr lang="en-US" sz="900" b="1" dirty="0">
+                <a:solidFill>
+                  <a:srgbClr val="F1F1F1"/>
+                </a:solidFill>
+                <a:latin typeface="Arial" pitchFamily="34" charset="0"/>
+                <a:ea typeface="Arial" pitchFamily="34" charset="-122"/>
+                <a:cs typeface="Arial" pitchFamily="34" charset="-120"/>
+              </a:rPr>
+              <a:t>Engagement by Language</a:t>
+            </a:r>
+            <a:endParaRPr lang="en-US" sz="900" dirty="0"/>
+          </a:p>
+        </p:txBody>
+      </p:sp>
+      <p:sp>
+        <p:nvSpPr>
+          <p:cNvPr id="38" name="Text 36"/>
+          <p:cNvSpPr/>
+          <p:nvPr/>
+        </p:nvSpPr>
+        <p:spPr>
+          <a:xfrm>
+            <a:off x="6871543" y="2145506"/>
+            <a:ext cx="1399431" cy="101501"/>
+          </a:xfrm>
+          <a:prstGeom prst="roundRect">
+            <a:avLst>
+              <a:gd name="adj" fmla="val 37537"/>
+            </a:avLst>
+          </a:prstGeom>
+          <a:solidFill>
+            <a:srgbClr val="2A2D3E"/>
+          </a:solidFill>
+          <a:ln/>
+        </p:spPr>
+        <p:txBody>
+          <a:bodyPr wrap="square" rtlCol="0" anchor="ctr"/>
+          <a:lstStyle/>
+          <a:p>
+            <a:pPr indent="0" marL="0">
+              <a:buNone/>
+            </a:pPr>
+            <a:endParaRPr lang="en-US" dirty="0"/>
+          </a:p>
+        </p:txBody>
+      </p:sp>
+      <p:sp>
+        <p:nvSpPr>
+          <p:cNvPr id="39" name="Text 37"/>
+          <p:cNvSpPr/>
+          <p:nvPr/>
+        </p:nvSpPr>
+        <p:spPr>
+          <a:xfrm>
+            <a:off x="6871543" y="2145506"/>
+            <a:ext cx="1189434" cy="101501"/>
+          </a:xfrm>
+          <a:prstGeom prst="roundRect">
+            <a:avLst>
+              <a:gd name="adj" fmla="val 37537"/>
+            </a:avLst>
+          </a:prstGeom>
+          <a:solidFill>
+            <a:srgbClr val="D4AF37"/>
+          </a:solidFill>
+          <a:ln/>
+        </p:spPr>
+        <p:txBody>
+          <a:bodyPr wrap="square" rtlCol="0" anchor="ctr"/>
+          <a:lstStyle/>
+          <a:p>
+            <a:pPr indent="0" marL="0">
+              <a:buNone/>
+            </a:pPr>
+            <a:endParaRPr lang="en-US" dirty="0"/>
+          </a:p>
+        </p:txBody>
+      </p:sp>
+      <p:sp>
+        <p:nvSpPr>
+          <p:cNvPr id="40" name="Text 38"/>
+          <p:cNvSpPr/>
+          <p:nvPr/>
+        </p:nvSpPr>
+        <p:spPr>
+          <a:xfrm>
+            <a:off x="6871543" y="2310408"/>
+            <a:ext cx="1399431" cy="101501"/>
+          </a:xfrm>
+          <a:prstGeom prst="roundRect">
+            <a:avLst>
+              <a:gd name="adj" fmla="val 37537"/>
+            </a:avLst>
+          </a:prstGeom>
+          <a:solidFill>
+            <a:srgbClr val="2A2D3E"/>
+          </a:solidFill>
+          <a:ln/>
+        </p:spPr>
+        <p:txBody>
+          <a:bodyPr wrap="square" rtlCol="0" anchor="ctr"/>
+          <a:lstStyle/>
+          <a:p>
+            <a:pPr indent="0" marL="0">
+              <a:buNone/>
+            </a:pPr>
+            <a:endParaRPr lang="en-US" dirty="0"/>
+          </a:p>
+        </p:txBody>
+      </p:sp>
+      <p:sp>
+        <p:nvSpPr>
+          <p:cNvPr id="41" name="Text 39"/>
+          <p:cNvSpPr/>
+          <p:nvPr/>
+        </p:nvSpPr>
+        <p:spPr>
+          <a:xfrm>
+            <a:off x="6871543" y="2310408"/>
+            <a:ext cx="1147465" cy="101501"/>
+          </a:xfrm>
+          <a:prstGeom prst="roundRect">
+            <a:avLst>
+              <a:gd name="adj" fmla="val 37537"/>
+            </a:avLst>
+          </a:prstGeom>
+          <a:solidFill>
+            <a:srgbClr val="10B981"/>
+          </a:solidFill>
+          <a:ln/>
+        </p:spPr>
+        <p:txBody>
+          <a:bodyPr wrap="square" rtlCol="0" anchor="ctr"/>
+          <a:lstStyle/>
+          <a:p>
+            <a:pPr indent="0" marL="0">
+              <a:buNone/>
+            </a:pPr>
+            <a:endParaRPr lang="en-US" dirty="0"/>
+          </a:p>
+        </p:txBody>
+      </p:sp>
+      <p:sp>
+        <p:nvSpPr>
+          <p:cNvPr id="42" name="Text 40"/>
+          <p:cNvSpPr/>
+          <p:nvPr/>
+        </p:nvSpPr>
+        <p:spPr>
+          <a:xfrm>
+            <a:off x="6871543" y="2475309"/>
+            <a:ext cx="1399431" cy="101501"/>
+          </a:xfrm>
+          <a:prstGeom prst="roundRect">
+            <a:avLst>
+              <a:gd name="adj" fmla="val 37537"/>
+            </a:avLst>
+          </a:prstGeom>
+          <a:solidFill>
+            <a:srgbClr val="2A2D3E"/>
+          </a:solidFill>
+          <a:ln/>
+        </p:spPr>
+        <p:txBody>
+          <a:bodyPr wrap="square" rtlCol="0" anchor="ctr"/>
+          <a:lstStyle/>
+          <a:p>
+            <a:pPr indent="0" marL="0">
+              <a:buNone/>
+            </a:pPr>
+            <a:endParaRPr lang="en-US" dirty="0"/>
+          </a:p>
+        </p:txBody>
+      </p:sp>
+      <p:sp>
+        <p:nvSpPr>
+          <p:cNvPr id="43" name="Text 41"/>
+          <p:cNvSpPr/>
+          <p:nvPr/>
+        </p:nvSpPr>
+        <p:spPr>
+          <a:xfrm>
+            <a:off x="6871543" y="2475309"/>
+            <a:ext cx="1105495" cy="101501"/>
+          </a:xfrm>
+          <a:prstGeom prst="roundRect">
+            <a:avLst>
+              <a:gd name="adj" fmla="val 37537"/>
+            </a:avLst>
+          </a:prstGeom>
+          <a:solidFill>
+            <a:srgbClr val="3B82F6"/>
+          </a:solidFill>
+          <a:ln/>
+        </p:spPr>
+        <p:txBody>
+          <a:bodyPr wrap="square" rtlCol="0" anchor="ctr"/>
+          <a:lstStyle/>
+          <a:p>
+            <a:pPr indent="0" marL="0">
+              <a:buNone/>
+            </a:pPr>
+            <a:endParaRPr lang="en-US" dirty="0"/>
+          </a:p>
+        </p:txBody>
+      </p:sp>
+      <p:sp>
+        <p:nvSpPr>
+          <p:cNvPr id="44" name="Text 42"/>
+          <p:cNvSpPr/>
+          <p:nvPr/>
+        </p:nvSpPr>
+        <p:spPr>
+          <a:xfrm>
+            <a:off x="6871543" y="2640211"/>
+            <a:ext cx="1399431" cy="101501"/>
+          </a:xfrm>
+          <a:prstGeom prst="roundRect">
+            <a:avLst>
+              <a:gd name="adj" fmla="val 37537"/>
+            </a:avLst>
+          </a:prstGeom>
+          <a:solidFill>
+            <a:srgbClr val="2A2D3E"/>
+          </a:solidFill>
+          <a:ln/>
+        </p:spPr>
+        <p:txBody>
+          <a:bodyPr wrap="square" rtlCol="0" anchor="ctr"/>
+          <a:lstStyle/>
+          <a:p>
+            <a:pPr indent="0" marL="0">
+              <a:buNone/>
+            </a:pPr>
+            <a:endParaRPr lang="en-US" dirty="0"/>
+          </a:p>
+        </p:txBody>
+      </p:sp>
+      <p:sp>
+        <p:nvSpPr>
+          <p:cNvPr id="45" name="Text 43"/>
+          <p:cNvSpPr/>
+          <p:nvPr/>
+        </p:nvSpPr>
+        <p:spPr>
+          <a:xfrm>
+            <a:off x="6871543" y="2640211"/>
+            <a:ext cx="1035546" cy="101501"/>
+          </a:xfrm>
+          <a:prstGeom prst="roundRect">
+            <a:avLst>
+              <a:gd name="adj" fmla="val 37537"/>
+            </a:avLst>
+          </a:prstGeom>
+          <a:solidFill>
+            <a:srgbClr val="8B5CF6"/>
+          </a:solidFill>
+          <a:ln/>
+        </p:spPr>
+        <p:txBody>
+          <a:bodyPr wrap="square" rtlCol="0" anchor="ctr"/>
+          <a:lstStyle/>
+          <a:p>
+            <a:pPr indent="0" marL="0">
+              <a:buNone/>
+            </a:pPr>
+            <a:endParaRPr lang="en-US" dirty="0"/>
+          </a:p>
+        </p:txBody>
+      </p:sp>
+      <p:sp>
+        <p:nvSpPr>
+          <p:cNvPr id="46" name="Text 44"/>
+          <p:cNvSpPr/>
+          <p:nvPr/>
+        </p:nvSpPr>
+        <p:spPr>
+          <a:xfrm>
+            <a:off x="6871543" y="2805113"/>
+            <a:ext cx="1399431" cy="101501"/>
+          </a:xfrm>
+          <a:prstGeom prst="roundRect">
+            <a:avLst>
+              <a:gd name="adj" fmla="val 37537"/>
+            </a:avLst>
+          </a:prstGeom>
+          <a:solidFill>
+            <a:srgbClr val="2A2D3E"/>
+          </a:solidFill>
+          <a:ln/>
+        </p:spPr>
+        <p:txBody>
+          <a:bodyPr wrap="square" rtlCol="0" anchor="ctr"/>
+          <a:lstStyle/>
+          <a:p>
+            <a:pPr indent="0" marL="0">
+              <a:buNone/>
+            </a:pPr>
+            <a:endParaRPr lang="en-US" dirty="0"/>
+          </a:p>
+        </p:txBody>
+      </p:sp>
+      <p:sp>
+        <p:nvSpPr>
+          <p:cNvPr id="47" name="Text 45"/>
+          <p:cNvSpPr/>
+          <p:nvPr/>
+        </p:nvSpPr>
+        <p:spPr>
+          <a:xfrm>
+            <a:off x="6871543" y="2805113"/>
+            <a:ext cx="993577" cy="101501"/>
+          </a:xfrm>
+          <a:prstGeom prst="roundRect">
+            <a:avLst>
+              <a:gd name="adj" fmla="val 37537"/>
+            </a:avLst>
+          </a:prstGeom>
+          <a:solidFill>
+            <a:srgbClr val="EC4899"/>
+          </a:solidFill>
+          <a:ln/>
+        </p:spPr>
+        <p:txBody>
+          <a:bodyPr wrap="square" rtlCol="0" anchor="ctr"/>
+          <a:lstStyle/>
+          <a:p>
+            <a:pPr indent="0" marL="0">
+              <a:buNone/>
+            </a:pPr>
+            <a:endParaRPr lang="en-US" dirty="0"/>
+          </a:p>
+        </p:txBody>
+      </p:sp>
+      <p:sp>
+        <p:nvSpPr>
+          <p:cNvPr id="48" name="Text 46"/>
+          <p:cNvSpPr/>
+          <p:nvPr/>
+        </p:nvSpPr>
+        <p:spPr>
+          <a:xfrm>
+            <a:off x="6871543" y="2970014"/>
+            <a:ext cx="1399431" cy="101501"/>
+          </a:xfrm>
+          <a:prstGeom prst="roundRect">
+            <a:avLst>
+              <a:gd name="adj" fmla="val 37537"/>
+            </a:avLst>
+          </a:prstGeom>
+          <a:solidFill>
+            <a:srgbClr val="2A2D3E"/>
+          </a:solidFill>
+          <a:ln/>
+        </p:spPr>
+        <p:txBody>
+          <a:bodyPr wrap="square" rtlCol="0" anchor="ctr"/>
+          <a:lstStyle/>
+          <a:p>
+            <a:pPr indent="0" marL="0">
+              <a:buNone/>
+            </a:pPr>
+            <a:endParaRPr lang="en-US" dirty="0"/>
+          </a:p>
+        </p:txBody>
+      </p:sp>
+      <p:sp>
+        <p:nvSpPr>
+          <p:cNvPr id="49" name="Text 47"/>
+          <p:cNvSpPr/>
+          <p:nvPr/>
+        </p:nvSpPr>
+        <p:spPr>
+          <a:xfrm>
+            <a:off x="6871543" y="2970014"/>
+            <a:ext cx="951607" cy="101501"/>
+          </a:xfrm>
+          <a:prstGeom prst="roundRect">
+            <a:avLst>
+              <a:gd name="adj" fmla="val 37537"/>
+            </a:avLst>
+          </a:prstGeom>
+          <a:solidFill>
+            <a:srgbClr val="F59E0B"/>
+          </a:solidFill>
+          <a:ln/>
+        </p:spPr>
+        <p:txBody>
+          <a:bodyPr wrap="square" rtlCol="0" anchor="ctr"/>
+          <a:lstStyle/>
+          <a:p>
+            <a:pPr indent="0" marL="0">
+              <a:buNone/>
+            </a:pPr>
+            <a:endParaRPr lang="en-US" dirty="0"/>
+          </a:p>
+        </p:txBody>
+      </p:sp>
+    </p:spTree>
+  </p:cSld>
+  <p:clrMapOvr>
+    <a:masterClrMapping/>
+  </p:clrMapOvr>
+</p:sld>
+</file>
+
+<file path=ppt/slides/slide11.xml><?xml version="1.0" encoding="utf-8"?>
+<p:sld xmlns:a="http://schemas.openxmlformats.org/drawingml/2006/main" xmlns:r="http://schemas.openxmlformats.org/officeDocument/2006/relationships" xmlns:p="http://schemas.openxmlformats.org/presentationml/2006/main">
+  <p:cSld name="Slide 11">
     <p:bg>
       <p:bgPr>
         <a:solidFill>

</xml_diff>